<commit_message>
feat(brand): Jaanta Hai Kya (JHK) — the question-mark monogram, the hand-drawn wordmark, and the name across the product
Mark, wordmark, lockup, favicon, apple-touch icon and social card are hand-drawn SVG paths in the
Floodlight palette, rendered as the top-bar brand, the desktop rail mark and a 6% hero watermark.
Titles, metadata, the rules and trust pages, the finish screen, the sign-in mail, the SEO chrome
and the investor deck now carry the name; code identifiers, storage keys and the repository name
stay as they were. docs/brand.md is the brand sheet, with the Devanagari slot reserved.

Co-Authored-By: Claude Fable 5.1 <noreply@anthropic.com>
Claude-Session: https://claude.ai/code/session_01SQxRPnTepp5DgBgEWKtQxD
</commit_message>
<xml_diff>
--- a/public/product/investor/factduel-seed-deck.pptx
+++ b/public/product/investor/factduel-seed-deck.pptx
@@ -4261,7 +4261,7 @@
           <a:p/>
           <a:p>
             <a:r>
-              <a:t>SOURCES — keep all four on the face: the Google Play Trivia Crack URL (https://play.google.com/store/apps/details?id=com.etermax.preguntados.lite&amp;hl=en_US&amp;gl=US), https://www.apptweak.com/, and "FACT//DUEL internal: numbers.md §2.1, §2.2, §3.5, §5.2 and §5.14 (company disclosure)". The headline still prints the departure claim in the largest type on the slide, so its source cannot come off.</a:t>
+              <a:t>SOURCES — keep all four on the face: the Google Play Trivia Crack URL (https://play.google.com/store/apps/details?id=com.etermax.preguntados.lite&amp;hl=en_US&amp;gl=US), https://www.apptweak.com/, and "Jaanta Hai Kya (JHK) internal: numbers.md §2.1, §2.2, §3.5, §5.2 and §5.14 (company disclosure)". The headline still prints the departure claim in the largest type on the slide, so its source cannot come off.</a:t>
             </a:r>
           </a:p>
           <a:p/>
@@ -4393,7 +4393,7 @@
           <a:p/>
           <a:p>
             <a:r>
-              <a:t>CHART: benchmark bars only. There is no FACT//DUEL bar because there is no FACT//DUEL rate. Say that when the chart goes up.</a:t>
+              <a:t>CHART: benchmark bars only. There is no Jaanta Hai Kya (JHK) bar because there is no Jaanta Hai Kya (JHK) rate. Say that when the chart goes up.</a:t>
             </a:r>
           </a:p>
           <a:p/>
@@ -7628,7 +7628,7 @@
                 </a:solidFill>
                 <a:latin typeface="Arial"/>
               </a:rPr>
-              <a:t>FACT</a:t>
+              <a:t>JAANTA</a:t>
             </a:r>
             <a:r>
               <a:rPr sz="6200" b="1" i="0" spc="50">
@@ -7637,7 +7637,7 @@
                 </a:solidFill>
                 <a:latin typeface="Arial"/>
               </a:rPr>
-              <a:t>//</a:t>
+              <a:t> HAI </a:t>
             </a:r>
             <a:r>
               <a:rPr sz="6200" b="1" i="0" spc="50">
@@ -7646,7 +7646,7 @@
                 </a:solidFill>
                 <a:latin typeface="Arial"/>
               </a:rPr>
-              <a:t>DUEL</a:t>
+              <a:t>KYA</a:t>
             </a:r>
           </a:p>
           <a:p>
@@ -7971,7 +7971,7 @@
                 </a:solidFill>
                 <a:latin typeface="Arial"/>
               </a:rPr>
-              <a:t>Confidential. For the named recipient only. Every number carries its source. Figures marked (P) are a plan, not a forecast; figures marked (likely) are third-party benchmarks the research could not independently verify. FACT//DUEL has no users outside a private playtest, no revenue, and takes no money from anyone.</a:t>
+              <a:t>Confidential. For the named recipient only. Every number carries its source. Figures marked (P) are a plan, not a forecast; figures marked (likely) are third-party benchmarks the research could not independently verify. Jaanta Hai Kya (JHK), formerly FACT//DUEL, has no users outside a private playtest, no revenue, and takes no money from anyone.</a:t>
             </a:r>
           </a:p>
         </p:txBody>
@@ -8418,7 +8418,7 @@
         </p:nvGraphicFramePr>
         <p:xfrm>
           <a:off x="566928" y="3592322"/>
-          <a:ext cx="11057837" cy="2314696"/>
+          <a:ext cx="11057836" cy="2314696"/>
         </p:xfrm>
         <a:graphic>
           <a:graphicData uri="http://schemas.openxmlformats.org/drawingml/2006/table">
@@ -8427,11 +8427,11 @@
                 <a:tableStyleId>{2D5ABB26-0587-4C30-8999-92F81FD0307C}</a:tableStyleId>
               </a:tblPr>
               <a:tblGrid>
-                <a:gridCol w="1690589"/>
-                <a:gridCol w="2795829"/>
-                <a:gridCol w="2549103"/>
-                <a:gridCol w="1402042"/>
-                <a:gridCol w="2620274"/>
+                <a:gridCol w="1679962"/>
+                <a:gridCol w="2799301"/>
+                <a:gridCol w="2551970"/>
+                <a:gridCol w="1402906"/>
+                <a:gridCol w="2623697"/>
               </a:tblGrid>
               <a:tr h="216784">
                 <a:tc>
@@ -9273,7 +9273,7 @@
                           </a:solidFill>
                           <a:latin typeface="Arial"/>
                         </a:rPr>
-                        <a:t>FACT//DUEL</a:t>
+                        <a:t>Jaanta Hai Kya (JHK)</a:t>
                       </a:r>
                     </a:p>
                   </a:txBody>
@@ -14853,7 +14853,7 @@
                 </a:solidFill>
                 <a:latin typeface="Arial"/>
               </a:rPr>
-              <a:t>Every number about FACT//DUEL: no DAU, no D1/D7/D30 rate, no session length, no conversion, no CAC, no LTV, no revenue. The instrument shipped; the players did not (§7.1).</a:t>
+              <a:t>Every number about Jaanta Hai Kya (JHK): no DAU, no D1/D7/D30 rate, no session length, no conversion, no CAC, no LTV, no revenue. The instrument shipped; the players did not (§7.1).</a:t>
             </a:r>
           </a:p>
           <a:p>

</xml_diff>

<commit_message>
docs: deck and money README updated for the 829-question bank and the M4 backend
Co-Authored-By: Claude Fable 5.1 <noreply@anthropic.com>
Claude-Session: https://claude.ai/code/session_01SQxRPnTepp5DgBgEWKtQxD
</commit_message>
<xml_diff>
--- a/public/product/investor/factduel-seed-deck.pptx
+++ b/public/product/investor/factduel-seed-deck.pptx
@@ -2021,7 +2021,7 @@
           <a:p/>
           <a:p>
             <a:r>
-              <a:t>The full shipped inventory in the static build (§7.2): bot duels in all three modes, expeditions, discovery, the vault, the passport with the Supporter Card and boards, the events calendar with fixture sets and the limited modes, the coin wallet with the priced ad card, and the Rules of the coin and Trust pages. Behind it, not reachable from the static build: the ledger persisted to D1 with every guard a constraint violation (tests/ledger-store.test.mjs runs one suite against the memory store and the D1 harness), a guest wallet route that issues a nonce per ad and posts each reward as a ledger grant, and an hourly reconcile that replays the books and goes red on drift.</a:t>
+              <a:t>The full shipped inventory in the static build (§7.2): bot duels in all three modes, expeditions, discovery, the vault, the passport with the Supporter Card and boards, the events calendar with fixture sets and the limited modes, the coin wallet with the priced ad card, and the Rules of the coin and Trust pages. Behind it, in the Worker build (Cloudflare deploy workflow in the repo): accounts by magic link and Google with the guest principal promoted in place, cross-device profile sync, a matchmaking queue with no fills, duel entries and prizes on the ledger, and the ledger persisted to D1 with every guard a constraint violation (tests/ledger-store.test.mjs runs one suite against the memory store and the D1 harness), a guest wallet route that issues a nonce per ad and posts each reward as a ledger grant, and an hourly reconcile that replays the books and goes red on drift.</a:t>
             </a:r>
           </a:p>
           <a:p/>
@@ -2033,7 +2033,7 @@
           <a:p/>
           <a:p>
             <a:r>
-              <a:t>Be exact about what it is and is not: no accounts and no server-side progression, the served bank is 329 sports questions, two-device friend duels are disabled in that build with an on-screen notice, it produces no retention data on its own, and nobody who opens it is a user in any sense this deck would count. There is no live feed, no scores service and no rights deal with any league, broadcaster or rights holder.</a:t>
+              <a:t>Be exact about what it is and is not: no accounts and no server-side progression, the served bank is 829 sports questions (565 cricket, 500 of them Indian cricket authored 17 September 2026), two-device friend duels are disabled in that build with an on-screen notice, it produces no retention data on its own, and nobody who opens it is a user in any sense this deck would count. There is no live feed, no scores service and no rights deal with any league, broadcaster or rights holder.</a:t>
             </a:r>
           </a:p>
           <a:p/>
@@ -29841,7 +29841,7 @@
           </a:bodyPr>
           <a:lstStyle/>
           <a:p>
-            <a:pPr marL="204478" indent="-204478">
+            <a:pPr marL="195961" indent="-195961">
               <a:lnSpc>
                 <a:spcPct val="116000"/>
               </a:lnSpc>
@@ -29852,7 +29852,7 @@
               <a:buChar char="—"/>
             </a:pPr>
             <a:r>
-              <a:rPr sz="1200" b="0" i="0">
+              <a:rPr sz="1150" b="0" i="0">
                 <a:solidFill>
                   <a:srgbClr val="F7F6EF"/>
                 </a:solidFill>
@@ -29862,12 +29862,12 @@
             </a:r>
           </a:p>
           <a:p>
-            <a:pPr marL="204478" indent="-204478">
+            <a:pPr marL="195961" indent="-195961">
               <a:lnSpc>
                 <a:spcPct val="116000"/>
               </a:lnSpc>
               <a:spcBef>
-                <a:spcPts val="660"/>
+                <a:spcPts val="632"/>
               </a:spcBef>
               <a:buClr>
                 <a:srgbClr val="D4FF3A"/>
@@ -29876,22 +29876,22 @@
               <a:buChar char="—"/>
             </a:pPr>
             <a:r>
-              <a:rPr sz="1200" b="0" i="0">
+              <a:rPr sz="1150" b="0" i="0">
                 <a:solidFill>
                   <a:srgbClr val="F7F6EF"/>
                 </a:solidFill>
                 <a:latin typeface="Arial"/>
               </a:rPr>
-              <a:t>Sports only since 16 Sep 2026: football, cricket, baseball, Formula 1 and basketball, 60-66 questions each. Science is hidden behind one flag, not deleted.</a:t>
-            </a:r>
-          </a:p>
-          <a:p>
-            <a:pPr marL="204478" indent="-204478">
+              <a:t>Sports only since 16 Sep 2026: football, cricket, baseball, Formula 1 and basketball. On 17 Sep the served bank reached 829 questions, 565 of them cricket (500 on Indian cricket, including 50 on the women's game), every fact checked against a fetched page by its author.</a:t>
+            </a:r>
+          </a:p>
+          <a:p>
+            <a:pPr marL="195961" indent="-195961">
               <a:lnSpc>
                 <a:spcPct val="116000"/>
               </a:lnSpc>
               <a:spcBef>
-                <a:spcPts val="660"/>
+                <a:spcPts val="632"/>
               </a:spcBef>
               <a:buClr>
                 <a:srgbClr val="D4FF3A"/>
@@ -29900,7 +29900,7 @@
               <a:buChar char="—"/>
             </a:pPr>
             <a:r>
-              <a:rPr sz="1200" b="0" i="0">
+              <a:rPr sz="1150" b="0" i="0">
                 <a:solidFill>
                   <a:srgbClr val="F7F6EF"/>
                 </a:solidFill>
@@ -29910,12 +29910,12 @@
             </a:r>
           </a:p>
           <a:p>
-            <a:pPr marL="204478" indent="-204478">
+            <a:pPr marL="195961" indent="-195961">
               <a:lnSpc>
                 <a:spcPct val="116000"/>
               </a:lnSpc>
               <a:spcBef>
-                <a:spcPts val="660"/>
+                <a:spcPts val="632"/>
               </a:spcBef>
               <a:buClr>
                 <a:srgbClr val="D4FF3A"/>
@@ -29924,7 +29924,7 @@
               <a:buChar char="—"/>
             </a:pPr>
             <a:r>
-              <a:rPr sz="1200" b="0" i="0">
+              <a:rPr sz="1150" b="0" i="0">
                 <a:solidFill>
                   <a:srgbClr val="F7F6EF"/>
                 </a:solidFill>
@@ -29934,12 +29934,12 @@
             </a:r>
           </a:p>
           <a:p>
-            <a:pPr marL="204478" indent="-204478">
+            <a:pPr marL="195961" indent="-195961">
               <a:lnSpc>
                 <a:spcPct val="116000"/>
               </a:lnSpc>
               <a:spcBef>
-                <a:spcPts val="660"/>
+                <a:spcPts val="632"/>
               </a:spcBef>
               <a:buClr>
                 <a:srgbClr val="D4FF3A"/>
@@ -29948,7 +29948,7 @@
               <a:buChar char="—"/>
             </a:pPr>
             <a:r>
-              <a:rPr sz="1200" b="0" i="0">
+              <a:rPr sz="1150" b="0" i="0">
                 <a:solidFill>
                   <a:srgbClr val="F7F6EF"/>
                 </a:solidFill>
@@ -29958,12 +29958,12 @@
             </a:r>
           </a:p>
           <a:p>
-            <a:pPr marL="204478" indent="-204478">
+            <a:pPr marL="195961" indent="-195961">
               <a:lnSpc>
                 <a:spcPct val="116000"/>
               </a:lnSpc>
               <a:spcBef>
-                <a:spcPts val="660"/>
+                <a:spcPts val="632"/>
               </a:spcBef>
               <a:buClr>
                 <a:srgbClr val="D4FF3A"/>
@@ -29972,7 +29972,7 @@
               <a:buChar char="—"/>
             </a:pPr>
             <a:r>
-              <a:rPr sz="1200" b="0" i="0">
+              <a:rPr sz="1150" b="0" i="0">
                 <a:solidFill>
                   <a:srgbClr val="F7F6EF"/>
                 </a:solidFill>

</xml_diff>